<commit_message>
Reporte en PPTX 260526
</commit_message>
<xml_diff>
--- a/Reporte 260526.pptx
+++ b/Reporte 260526.pptx
@@ -6962,6 +6962,36 @@
           </a:p>
         </p:txBody>
       </p:sp>
+      <p:pic>
+        <p:nvPicPr>
+          <p:cNvPr id="5" name="Imagen 4">
+            <a:extLst>
+              <a:ext uri="{FF2B5EF4-FFF2-40B4-BE49-F238E27FC236}">
+                <a16:creationId xmlns:a16="http://schemas.microsoft.com/office/drawing/2014/main" id="{9EFC69BF-0466-B27F-44C1-D10432B3B902}"/>
+              </a:ext>
+            </a:extLst>
+          </p:cNvPr>
+          <p:cNvPicPr>
+            <a:picLocks noChangeAspect="1"/>
+          </p:cNvPicPr>
+          <p:nvPr/>
+        </p:nvPicPr>
+        <p:blipFill>
+          <a:blip r:embed="rId2"/>
+          <a:stretch>
+            <a:fillRect/>
+          </a:stretch>
+        </p:blipFill>
+        <p:spPr>
+          <a:xfrm>
+            <a:off x="0" y="646567"/>
+            <a:ext cx="9144000" cy="3850366"/>
+          </a:xfrm>
+          <a:prstGeom prst="rect">
+            <a:avLst/>
+          </a:prstGeom>
+        </p:spPr>
+      </p:pic>
     </p:spTree>
     <p:extLst>
       <p:ext uri="{BB962C8B-B14F-4D97-AF65-F5344CB8AC3E}">
@@ -7042,10 +7072,10 @@
       </p:sp>
       <p:pic>
         <p:nvPicPr>
-          <p:cNvPr id="6" name="Imagen 5">
+          <p:cNvPr id="5" name="Imagen 4">
             <a:extLst>
               <a:ext uri="{FF2B5EF4-FFF2-40B4-BE49-F238E27FC236}">
-                <a16:creationId xmlns:a16="http://schemas.microsoft.com/office/drawing/2014/main" id="{E5708900-7912-E1B7-19B1-23A9CC4EDC1D}"/>
+                <a16:creationId xmlns:a16="http://schemas.microsoft.com/office/drawing/2014/main" id="{E02B3D4A-46F2-84F2-3F15-620D3EE0CD1A}"/>
               </a:ext>
             </a:extLst>
           </p:cNvPr>
@@ -7062,8 +7092,8 @@
         </p:blipFill>
         <p:spPr>
           <a:xfrm>
-            <a:off x="0" y="1255393"/>
-            <a:ext cx="9144000" cy="2775590"/>
+            <a:off x="0" y="1174543"/>
+            <a:ext cx="9144000" cy="2794414"/>
           </a:xfrm>
           <a:prstGeom prst="rect">
             <a:avLst/>
@@ -7156,10 +7186,10 @@
       </p:sp>
       <p:pic>
         <p:nvPicPr>
-          <p:cNvPr id="2" name="Imagen 1">
+          <p:cNvPr id="4" name="Imagen 3">
             <a:extLst>
               <a:ext uri="{FF2B5EF4-FFF2-40B4-BE49-F238E27FC236}">
-                <a16:creationId xmlns:a16="http://schemas.microsoft.com/office/drawing/2014/main" id="{9657BFFB-063A-5563-BA19-2966ED445774}"/>
+                <a16:creationId xmlns:a16="http://schemas.microsoft.com/office/drawing/2014/main" id="{E5624F94-0DDE-1382-8F6A-0A16D7D3C6C4}"/>
               </a:ext>
             </a:extLst>
           </p:cNvPr>
@@ -7176,8 +7206,8 @@
         </p:blipFill>
         <p:spPr>
           <a:xfrm>
-            <a:off x="793007" y="597488"/>
-            <a:ext cx="7484961" cy="4269712"/>
+            <a:off x="1149897" y="691088"/>
+            <a:ext cx="6844205" cy="3904200"/>
           </a:xfrm>
           <a:prstGeom prst="rect">
             <a:avLst/>
@@ -7260,10 +7290,10 @@
       </p:sp>
       <p:pic>
         <p:nvPicPr>
-          <p:cNvPr id="4" name="Imagen 3">
+          <p:cNvPr id="3" name="Imagen 2">
             <a:extLst>
               <a:ext uri="{FF2B5EF4-FFF2-40B4-BE49-F238E27FC236}">
-                <a16:creationId xmlns:a16="http://schemas.microsoft.com/office/drawing/2014/main" id="{FA83E319-B395-9F9F-561F-D8967F51D898}"/>
+                <a16:creationId xmlns:a16="http://schemas.microsoft.com/office/drawing/2014/main" id="{B84F1833-C635-0EAB-EA66-5A0D226FA8DF}"/>
               </a:ext>
             </a:extLst>
           </p:cNvPr>
@@ -7280,8 +7310,8 @@
         </p:blipFill>
         <p:spPr>
           <a:xfrm>
-            <a:off x="589994" y="1190423"/>
-            <a:ext cx="7964011" cy="2905530"/>
+            <a:off x="632863" y="309247"/>
+            <a:ext cx="7878274" cy="4525006"/>
           </a:xfrm>
           <a:prstGeom prst="rect">
             <a:avLst/>
@@ -7374,10 +7404,10 @@
       </p:sp>
       <p:pic>
         <p:nvPicPr>
-          <p:cNvPr id="6" name="Imagen 5">
+          <p:cNvPr id="3" name="Imagen 2">
             <a:extLst>
               <a:ext uri="{FF2B5EF4-FFF2-40B4-BE49-F238E27FC236}">
-                <a16:creationId xmlns:a16="http://schemas.microsoft.com/office/drawing/2014/main" id="{9EFFE806-38E2-07ED-B92B-2621C3F51B16}"/>
+                <a16:creationId xmlns:a16="http://schemas.microsoft.com/office/drawing/2014/main" id="{2FCBB340-D6DD-F5E1-76CF-92D1354C0033}"/>
               </a:ext>
             </a:extLst>
           </p:cNvPr>
@@ -7394,8 +7424,8 @@
         </p:blipFill>
         <p:spPr>
           <a:xfrm>
-            <a:off x="0" y="690319"/>
-            <a:ext cx="9144000" cy="3762862"/>
+            <a:off x="0" y="740247"/>
+            <a:ext cx="9144000" cy="3805881"/>
           </a:xfrm>
           <a:prstGeom prst="rect">
             <a:avLst/>
@@ -7488,10 +7518,10 @@
       </p:sp>
       <p:pic>
         <p:nvPicPr>
-          <p:cNvPr id="6" name="Imagen 5">
+          <p:cNvPr id="2" name="Imagen 1">
             <a:extLst>
               <a:ext uri="{FF2B5EF4-FFF2-40B4-BE49-F238E27FC236}">
-                <a16:creationId xmlns:a16="http://schemas.microsoft.com/office/drawing/2014/main" id="{EF1F0743-A88B-A82B-6C0C-DDAA7BCD78AD}"/>
+                <a16:creationId xmlns:a16="http://schemas.microsoft.com/office/drawing/2014/main" id="{67AC3E6B-1D37-5CF9-65AA-0EC6B7C0FACB}"/>
               </a:ext>
             </a:extLst>
           </p:cNvPr>
@@ -7509,7 +7539,7 @@
         <p:spPr>
           <a:xfrm>
             <a:off x="1" y="691088"/>
-            <a:ext cx="4535488" cy="3904200"/>
+            <a:ext cx="4572000" cy="3904200"/>
           </a:xfrm>
           <a:prstGeom prst="rect">
             <a:avLst/>
@@ -7518,10 +7548,10 @@
       </p:pic>
       <p:pic>
         <p:nvPicPr>
-          <p:cNvPr id="7" name="Imagen 6">
+          <p:cNvPr id="3" name="Imagen 2">
             <a:extLst>
               <a:ext uri="{FF2B5EF4-FFF2-40B4-BE49-F238E27FC236}">
-                <a16:creationId xmlns:a16="http://schemas.microsoft.com/office/drawing/2014/main" id="{1DF3ED15-3EA1-D24F-9B70-4EDFA6BBC78E}"/>
+                <a16:creationId xmlns:a16="http://schemas.microsoft.com/office/drawing/2014/main" id="{1147DC79-9BCE-AA5F-05FD-83E221E73F4B}"/>
               </a:ext>
             </a:extLst>
           </p:cNvPr>
@@ -7538,8 +7568,8 @@
         </p:blipFill>
         <p:spPr>
           <a:xfrm>
-            <a:off x="4608512" y="691088"/>
-            <a:ext cx="4535488" cy="3904200"/>
+            <a:off x="4535487" y="727144"/>
+            <a:ext cx="4608512" cy="3832088"/>
           </a:xfrm>
           <a:prstGeom prst="rect">
             <a:avLst/>
@@ -7616,10 +7646,10 @@
       </p:sp>
       <p:pic>
         <p:nvPicPr>
-          <p:cNvPr id="4" name="Imagen 3">
+          <p:cNvPr id="3" name="Imagen 2">
             <a:extLst>
               <a:ext uri="{FF2B5EF4-FFF2-40B4-BE49-F238E27FC236}">
-                <a16:creationId xmlns:a16="http://schemas.microsoft.com/office/drawing/2014/main" id="{7453ADB3-2BB8-95A7-7663-A86E93E134F1}"/>
+                <a16:creationId xmlns:a16="http://schemas.microsoft.com/office/drawing/2014/main" id="{A67E415B-57D3-62ED-44E7-E427BE7DBC2D}"/>
               </a:ext>
             </a:extLst>
           </p:cNvPr>
@@ -7636,8 +7666,8 @@
         </p:blipFill>
         <p:spPr>
           <a:xfrm>
-            <a:off x="1421834" y="1433867"/>
-            <a:ext cx="6227307" cy="2418641"/>
+            <a:off x="1442601" y="885589"/>
+            <a:ext cx="6258798" cy="3372321"/>
           </a:xfrm>
           <a:prstGeom prst="rect">
             <a:avLst/>

</xml_diff>